<commit_message>
fix(ode): recalibrate endogenous inflow (P0 = g I) and guard policy counterfactuals; regenerate full-cohort results, figures and manuscripts
- ode_model_endogenous.py now calibrates I0 so total equilibrium inflow matches observed I, keeping all civilisations including Japanese and aligning T_equilibrium with the non-endogenous model.

- policy_counterfactuals.py skips missing groups instead of crashing.

- reproduce.sh completed end-to-end on the 723,647-author cohort; all results/ docs/ and figures updated.

Co-Authored-By: Tatsuki Onishi <bougtoir@gmail.com>
</commit_message>
<xml_diff>
--- a/researcher_mobility_ode/docs/annual_rates_projection_figures.pptx
+++ b/researcher_mobility_ode/docs/annual_rates_projection_figures.pptx
@@ -3242,7 +3242,7 @@
         <p:spPr>
           <a:xfrm>
             <a:off x="640080" y="1097280"/>
-            <a:ext cx="10972800" cy="9085171"/>
+            <a:ext cx="10972800" cy="8840963"/>
           </a:xfrm>
           <a:prstGeom prst="rect">
             <a:avLst/>
@@ -3346,7 +3346,7 @@
         <p:spPr>
           <a:xfrm>
             <a:off x="640080" y="1097280"/>
-            <a:ext cx="10972800" cy="7000048"/>
+            <a:ext cx="10972800" cy="6998581"/>
           </a:xfrm>
           <a:prstGeom prst="rect">
             <a:avLst/>

</xml_diff>